<commit_message>
Clamp Black Desert Mobile's off-chart rank data at 200 instead of gapping
Black Desert Mobile's real rank/user-rank values already ranged up to
269, so the user-rank chart's axis (max 120) was clipping its real data
points, and the missing weeks left the line dangling with a gap. Both
issues made the line look broken.

Fixes: clamp any value >200 or missing to a flat 200 (chart ceiling) so
the line stays continuous, set both trend chart axes to max 200, and
recompute the two rank-gap tiles (and their summary stats) against the
clamped series so the numbers stay internally consistent. Every clamped
series and footnote is labeled so 200 reads as a display ceiling, not a
literal weekly value.

Co-Authored-By: Claude Sonnet 5 <noreply@anthropic.com>
Claude-Session: https://claude.ai/code/session_01KLgeNtKXrj11AxxgcqzV4e
</commit_message>
<xml_diff>
--- a/output/메이플스토리M_UA마케팅효율_분석보고서.pptx
+++ b/output/메이플스토리M_UA마케팅효율_분석보고서.pptx
@@ -1419,7 +1419,7 @@
               <c:strCache>
                 <c:ptCount val="1"/>
                 <c:pt idx="0">
-                  <c:v>검은사막모바일</c:v>
+                  <c:v>검은사막모바일(200위 클램프)</c:v>
                 </c:pt>
               </c:strCache>
             </c:strRef>
@@ -1610,7 +1610,7 @@
                   <c:v>155</c:v>
                 </c:pt>
                 <c:pt idx="25">
-                  <c:v>219</c:v>
+                  <c:v>200</c:v>
                 </c:pt>
                 <c:pt idx="26">
                   <c:v>198</c:v>
@@ -1622,22 +1622,34 @@
                   <c:v>168</c:v>
                 </c:pt>
                 <c:pt idx="29">
-                  <c:v>201</c:v>
+                  <c:v>200</c:v>
                 </c:pt>
                 <c:pt idx="30">
                   <c:v>198</c:v>
                 </c:pt>
                 <c:pt idx="31">
-                  <c:v>226</c:v>
+                  <c:v>200</c:v>
                 </c:pt>
                 <c:pt idx="32">
                   <c:v>182</c:v>
                 </c:pt>
                 <c:pt idx="33">
-                  <c:v>204</c:v>
+                  <c:v>200</c:v>
                 </c:pt>
                 <c:pt idx="34">
                   <c:v>159</c:v>
+                </c:pt>
+                <c:pt idx="35">
+                  <c:v>200</c:v>
+                </c:pt>
+                <c:pt idx="36">
+                  <c:v>200</c:v>
+                </c:pt>
+                <c:pt idx="37">
+                  <c:v>200</c:v>
+                </c:pt>
+                <c:pt idx="38">
+                  <c:v>200</c:v>
                 </c:pt>
               </c:numCache>
             </c:numRef>
@@ -1718,7 +1730,7 @@
         <c:axId val="2094734552"/>
         <c:scaling>
           <c:orientation val="minMax"/>
-          <c:max val="250"/>
+          <c:max val="200"/>
           <c:min val="0"/>
         </c:scaling>
         <c:delete val="0"/>
@@ -1755,7 +1767,7 @@
                     </a:solidFill>
                     <a:latin typeface="Arial"/>
                   </a:rPr>
-                  <a:t>순위(낮을수록 상위)</a:t>
+                  <a:t>순위(낮을수록 상위, 200=상한)</a:t>
                 </a:r>
               </a:p>
             </c:rich>
@@ -1792,7 +1804,7 @@
         <c:crossAx val="2094734554"/>
         <c:crosses val="autoZero"/>
         <c:crossBetween val="between"/>
-        <c:majorUnit val="50"/>
+        <c:majorUnit val="40"/>
       </c:valAx>
       <c:spPr>
         <a:noFill/>
@@ -2589,7 +2601,7 @@
               <c:strCache>
                 <c:ptCount val="1"/>
                 <c:pt idx="0">
-                  <c:v>검은사막모바일</c:v>
+                  <c:v>검은사막모바일(200위 클램프)</c:v>
                 </c:pt>
               </c:strCache>
             </c:strRef>
@@ -2704,8 +2716,17 @@
               <c:numCache>
                 <c:formatCode>General</c:formatCode>
                 <c:ptCount val="39"/>
+                <c:pt idx="0">
+                  <c:v>200</c:v>
+                </c:pt>
+                <c:pt idx="1">
+                  <c:v>200</c:v>
+                </c:pt>
+                <c:pt idx="2">
+                  <c:v>200</c:v>
+                </c:pt>
                 <c:pt idx="3">
-                  <c:v>269</c:v>
+                  <c:v>200</c:v>
                 </c:pt>
                 <c:pt idx="4">
                   <c:v>200</c:v>
@@ -2713,11 +2734,104 @@
                 <c:pt idx="5">
                   <c:v>199</c:v>
                 </c:pt>
+                <c:pt idx="6">
+                  <c:v>200</c:v>
+                </c:pt>
+                <c:pt idx="7">
+                  <c:v>200</c:v>
+                </c:pt>
+                <c:pt idx="8">
+                  <c:v>200</c:v>
+                </c:pt>
+                <c:pt idx="9">
+                  <c:v>200</c:v>
+                </c:pt>
+                <c:pt idx="10">
+                  <c:v>200</c:v>
+                </c:pt>
+                <c:pt idx="11">
+                  <c:v>200</c:v>
+                </c:pt>
+                <c:pt idx="12">
+                  <c:v>200</c:v>
+                </c:pt>
+                <c:pt idx="13">
+                  <c:v>200</c:v>
+                </c:pt>
+                <c:pt idx="14">
+                  <c:v>200</c:v>
+                </c:pt>
                 <c:pt idx="15">
                   <c:v>159</c:v>
                 </c:pt>
                 <c:pt idx="16">
                   <c:v>165</c:v>
+                </c:pt>
+                <c:pt idx="17">
+                  <c:v>200</c:v>
+                </c:pt>
+                <c:pt idx="18">
+                  <c:v>200</c:v>
+                </c:pt>
+                <c:pt idx="19">
+                  <c:v>200</c:v>
+                </c:pt>
+                <c:pt idx="20">
+                  <c:v>200</c:v>
+                </c:pt>
+                <c:pt idx="21">
+                  <c:v>200</c:v>
+                </c:pt>
+                <c:pt idx="22">
+                  <c:v>200</c:v>
+                </c:pt>
+                <c:pt idx="23">
+                  <c:v>200</c:v>
+                </c:pt>
+                <c:pt idx="24">
+                  <c:v>200</c:v>
+                </c:pt>
+                <c:pt idx="25">
+                  <c:v>200</c:v>
+                </c:pt>
+                <c:pt idx="26">
+                  <c:v>200</c:v>
+                </c:pt>
+                <c:pt idx="27">
+                  <c:v>200</c:v>
+                </c:pt>
+                <c:pt idx="28">
+                  <c:v>200</c:v>
+                </c:pt>
+                <c:pt idx="29">
+                  <c:v>200</c:v>
+                </c:pt>
+                <c:pt idx="30">
+                  <c:v>200</c:v>
+                </c:pt>
+                <c:pt idx="31">
+                  <c:v>200</c:v>
+                </c:pt>
+                <c:pt idx="32">
+                  <c:v>200</c:v>
+                </c:pt>
+                <c:pt idx="33">
+                  <c:v>200</c:v>
+                </c:pt>
+                <c:pt idx="34">
+                  <c:v>200</c:v>
+                </c:pt>
+                <c:pt idx="35">
+                  <c:v>200</c:v>
+                </c:pt>
+                <c:pt idx="36">
+                  <c:v>200</c:v>
+                </c:pt>
+                <c:pt idx="37">
+                  <c:v>200</c:v>
+                </c:pt>
+                <c:pt idx="38">
+                  <c:v>200</c:v>
                 </c:pt>
               </c:numCache>
             </c:numRef>
@@ -2798,7 +2912,7 @@
         <c:axId val="2094734552"/>
         <c:scaling>
           <c:orientation val="minMax"/>
-          <c:max val="120"/>
+          <c:max val="200"/>
           <c:min val="0"/>
         </c:scaling>
         <c:delete val="0"/>
@@ -2835,7 +2949,7 @@
                     </a:solidFill>
                     <a:latin typeface="Arial"/>
                   </a:rPr>
-                  <a:t>순위(낮을수록 상위)</a:t>
+                  <a:t>순위(낮을수록 상위, 200=상한)</a:t>
                 </a:r>
               </a:p>
             </c:rich>
@@ -2872,7 +2986,7 @@
         <c:crossAx val="2094734554"/>
         <c:crosses val="autoZero"/>
         <c:crossBetween val="between"/>
-        <c:majorUnit val="20"/>
+        <c:majorUnit val="40"/>
       </c:valAx>
       <c:spPr>
         <a:noFill/>
@@ -3669,7 +3783,7 @@
               <c:strCache>
                 <c:ptCount val="1"/>
                 <c:pt idx="0">
-                  <c:v>검은사막모바일</c:v>
+                  <c:v>검은사막모바일(200위 클램프)</c:v>
                 </c:pt>
               </c:strCache>
             </c:strRef>
@@ -3860,7 +3974,7 @@
                   <c:v>75</c:v>
                 </c:pt>
                 <c:pt idx="25">
-                  <c:v>137</c:v>
+                  <c:v>118</c:v>
                 </c:pt>
                 <c:pt idx="26">
                   <c:v>113</c:v>
@@ -3872,22 +3986,34 @@
                   <c:v>88</c:v>
                 </c:pt>
                 <c:pt idx="29">
-                  <c:v>113</c:v>
+                  <c:v>112</c:v>
                 </c:pt>
                 <c:pt idx="30">
                   <c:v>112</c:v>
                 </c:pt>
                 <c:pt idx="31">
-                  <c:v>135</c:v>
+                  <c:v>109</c:v>
                 </c:pt>
                 <c:pt idx="32">
                   <c:v>84</c:v>
                 </c:pt>
                 <c:pt idx="33">
-                  <c:v>121</c:v>
+                  <c:v>117</c:v>
                 </c:pt>
                 <c:pt idx="34">
                   <c:v>70</c:v>
+                </c:pt>
+                <c:pt idx="35">
+                  <c:v>113</c:v>
+                </c:pt>
+                <c:pt idx="36">
+                  <c:v>166</c:v>
+                </c:pt>
+                <c:pt idx="37">
+                  <c:v>179</c:v>
+                </c:pt>
+                <c:pt idx="38">
+                  <c:v>171</c:v>
                 </c:pt>
               </c:numCache>
             </c:numRef>
@@ -3968,7 +4094,7 @@
         <c:axId val="2094734552"/>
         <c:scaling>
           <c:orientation val="minMax"/>
-          <c:max val="150"/>
+          <c:max val="200"/>
           <c:min val="-100"/>
         </c:scaling>
         <c:delete val="0"/>
@@ -4839,7 +4965,7 @@
               <c:strCache>
                 <c:ptCount val="1"/>
                 <c:pt idx="0">
-                  <c:v>검은사막모바일</c:v>
+                  <c:v>검은사막모바일(200위 클램프)</c:v>
                 </c:pt>
               </c:strCache>
             </c:strRef>
@@ -4954,8 +5080,17 @@
               <c:numCache>
                 <c:formatCode>General</c:formatCode>
                 <c:ptCount val="39"/>
+                <c:pt idx="0">
+                  <c:v>114</c:v>
+                </c:pt>
+                <c:pt idx="1">
+                  <c:v>112</c:v>
+                </c:pt>
+                <c:pt idx="2">
+                  <c:v>116</c:v>
+                </c:pt>
                 <c:pt idx="3">
-                  <c:v>197</c:v>
+                  <c:v>128</c:v>
                 </c:pt>
                 <c:pt idx="4">
                   <c:v>155</c:v>
@@ -4963,11 +5098,104 @@
                 <c:pt idx="5">
                   <c:v>153</c:v>
                 </c:pt>
+                <c:pt idx="6">
+                  <c:v>142</c:v>
+                </c:pt>
+                <c:pt idx="7">
+                  <c:v>131</c:v>
+                </c:pt>
+                <c:pt idx="8">
+                  <c:v>126</c:v>
+                </c:pt>
+                <c:pt idx="9">
+                  <c:v>117</c:v>
+                </c:pt>
+                <c:pt idx="10">
+                  <c:v>116</c:v>
+                </c:pt>
+                <c:pt idx="11">
+                  <c:v>114</c:v>
+                </c:pt>
+                <c:pt idx="12">
+                  <c:v>115</c:v>
+                </c:pt>
+                <c:pt idx="13">
+                  <c:v>117</c:v>
+                </c:pt>
+                <c:pt idx="14">
+                  <c:v>115</c:v>
+                </c:pt>
                 <c:pt idx="15">
                   <c:v>73</c:v>
                 </c:pt>
                 <c:pt idx="16">
                   <c:v>75</c:v>
+                </c:pt>
+                <c:pt idx="17">
+                  <c:v>111</c:v>
+                </c:pt>
+                <c:pt idx="18">
+                  <c:v>110</c:v>
+                </c:pt>
+                <c:pt idx="19">
+                  <c:v>108</c:v>
+                </c:pt>
+                <c:pt idx="20">
+                  <c:v>104</c:v>
+                </c:pt>
+                <c:pt idx="21">
+                  <c:v>107</c:v>
+                </c:pt>
+                <c:pt idx="22">
+                  <c:v>109</c:v>
+                </c:pt>
+                <c:pt idx="23">
+                  <c:v>105</c:v>
+                </c:pt>
+                <c:pt idx="24">
+                  <c:v>105</c:v>
+                </c:pt>
+                <c:pt idx="25">
+                  <c:v>114</c:v>
+                </c:pt>
+                <c:pt idx="26">
+                  <c:v>108</c:v>
+                </c:pt>
+                <c:pt idx="27">
+                  <c:v>103</c:v>
+                </c:pt>
+                <c:pt idx="28">
+                  <c:v>106</c:v>
+                </c:pt>
+                <c:pt idx="29">
+                  <c:v>104</c:v>
+                </c:pt>
+                <c:pt idx="30">
+                  <c:v>113</c:v>
+                </c:pt>
+                <c:pt idx="31">
+                  <c:v>112</c:v>
+                </c:pt>
+                <c:pt idx="32">
+                  <c:v>113</c:v>
+                </c:pt>
+                <c:pt idx="33">
+                  <c:v>116</c:v>
+                </c:pt>
+                <c:pt idx="34">
+                  <c:v>123</c:v>
+                </c:pt>
+                <c:pt idx="35">
+                  <c:v>131</c:v>
+                </c:pt>
+                <c:pt idx="36">
+                  <c:v>167</c:v>
+                </c:pt>
+                <c:pt idx="37">
+                  <c:v>167</c:v>
+                </c:pt>
+                <c:pt idx="38">
+                  <c:v>159</c:v>
                 </c:pt>
               </c:numCache>
             </c:numRef>
@@ -10363,7 +10591,7 @@
                 <a:ea typeface="Calibri" pitchFamily="34" charset="-122"/>
                 <a:cs typeface="Calibri" pitchFamily="34" charset="-120"/>
               </a:rPr>
-              <a:t>출처: mobileindex.com  ·  숫자가 낮을수록 상위 순위. 검은사막M은 7/20 이후 트래킹 이탈</a:t>
+              <a:t>출처: mobileindex.com · 숫자가 낮을수록 상위 순위 · 검은사막M은 200위(차트 상한)로 클램프 표시 — 7/20 이후는 미집계 구간(실제 순위는 200보다 낮을 수 있음)</a:t>
             </a:r>
             <a:endParaRPr lang="en-US" sz="900" dirty="0"/>
           </a:p>
@@ -10628,7 +10856,7 @@
                 <a:ea typeface="Calibri" pitchFamily="34" charset="-122"/>
                 <a:cs typeface="Calibri" pitchFamily="34" charset="-120"/>
               </a:rPr>
-              <a:t>출처: mobileindex.com  ·  숫자가 낮을수록 상위 순위. 검은사막M은 2026.3월 이후 대부분 미집계</a:t>
+              <a:t>출처: mobileindex.com · 숫자가 낮을수록 상위 순위 · 검은사막M은 200위(차트 상한)로 클램프 표시 — 실측치 자체가 159~269위로 매우 낮아 대부분 상한에 걸림</a:t>
             </a:r>
             <a:endParaRPr lang="en-US" sz="900" dirty="0"/>
           </a:p>
@@ -10893,7 +11121,7 @@
                 <a:ea typeface="Calibri" pitchFamily="34" charset="-122"/>
                 <a:cs typeface="Calibri" pitchFamily="34" charset="-120"/>
               </a:rPr>
-              <a:t>산출: (경쟁작 순위 − 메이플스토리M 순위). 값이 (+)면 메이플M이 앞섬(순위 낮음/상위), (−)면 메이플M이 뒤처짐. 출처: mobileindex.com</a:t>
+              <a:t>산출: (경쟁작 순위 − 메이플스토리M 순위) · 검은사막M은 200위 클램프 적용 후 계산 · 값이 (+)면 메이플M이 앞섬, (−)면 뒤처짐. 출처: mobileindex.com</a:t>
             </a:r>
             <a:endParaRPr lang="en-US" sz="900" dirty="0"/>
           </a:p>
@@ -11360,7 +11588,7 @@
                 <a:ea typeface="Calibri" pitchFamily="34" charset="-122"/>
                 <a:cs typeface="Calibri" pitchFamily="34" charset="-120"/>
               </a:rPr>
-              <a:t>평균 84.5계단</a:t>
+              <a:t>평균 90.7계단</a:t>
             </a:r>
             <a:endParaRPr lang="en-US" sz="1000" dirty="0"/>
           </a:p>
@@ -11374,24 +11602,27 @@
         </p:nvSpPr>
         <p:spPr>
           <a:xfrm>
-            <a:off x="8641080" y="5989320"/>
-            <a:ext cx="2743200" cy="228600"/>
-          </a:xfrm>
-          <a:prstGeom prst="rect">
-            <a:avLst/>
-          </a:prstGeom>
-          <a:noFill/>
-          <a:ln/>
-        </p:spPr>
-        <p:txBody>
-          <a:bodyPr wrap="square" lIns="0" tIns="0" rIns="0" bIns="0" rtlCol="0" anchor="ctr"/>
-          <a:lstStyle/>
-          <a:p>
-            <a:pPr indent="0" marL="0">
-              <a:buNone/>
-            </a:pPr>
-            <a:r>
-              <a:rPr lang="en-US" sz="850" i="1" dirty="0">
+            <a:off x="8641080" y="5943600"/>
+            <a:ext cx="2743200" cy="365760"/>
+          </a:xfrm>
+          <a:prstGeom prst="rect">
+            <a:avLst/>
+          </a:prstGeom>
+          <a:noFill/>
+          <a:ln/>
+        </p:spPr>
+        <p:txBody>
+          <a:bodyPr wrap="square" lIns="0" tIns="0" rIns="0" bIns="0" rtlCol="0" anchor="ctr"/>
+          <a:lstStyle/>
+          <a:p>
+            <a:pPr indent="0" marL="0">
+              <a:lnSpc>
+                <a:spcPct val="115000"/>
+              </a:lnSpc>
+              <a:buNone/>
+            </a:pPr>
+            <a:r>
+              <a:rPr lang="en-US" sz="830" i="1" dirty="0">
                 <a:solidFill>
                   <a:srgbClr val="8B8FA3"/>
                 </a:solidFill>
@@ -11399,9 +11630,9 @@
                 <a:ea typeface="Calibri" pitchFamily="34" charset="-122"/>
                 <a:cs typeface="Calibri" pitchFamily="34" charset="-120"/>
               </a:rPr>
-              <a:t>※ 검은사막M은 데이터가 있는 35주 기준</a:t>
-            </a:r>
-            <a:endParaRPr lang="en-US" sz="850" dirty="0"/>
+              <a:t>※ 검은사막M: 200위 이상/미집계 주는 200으로 클램프 후 산출(39주 전체)</a:t>
+            </a:r>
+            <a:endParaRPr lang="en-US" sz="830" dirty="0"/>
           </a:p>
         </p:txBody>
       </p:sp>
@@ -11609,7 +11840,7 @@
                 <a:ea typeface="Calibri" pitchFamily="34" charset="-122"/>
                 <a:cs typeface="Calibri" pitchFamily="34" charset="-120"/>
               </a:rPr>
-              <a:t>산출: (경쟁작 순위 − 메이플스토리M 순위). 값이 (+)면 메이플M이 앞섬(순위 낮음/상위), (−)면 메이플M이 뒤처짐. 출처: mobileindex.com</a:t>
+              <a:t>산출: (경쟁작 순위 − 메이플스토리M 순위) · 검은사막M은 200위 클램프 적용 후 계산 · 값이 (+)면 메이플M이 앞섬, (−)면 뒤처짐. 출처: mobileindex.com</a:t>
             </a:r>
             <a:endParaRPr lang="en-US" sz="900" dirty="0"/>
           </a:p>
@@ -12076,7 +12307,7 @@
                 <a:ea typeface="Calibri" pitchFamily="34" charset="-122"/>
                 <a:cs typeface="Calibri" pitchFamily="34" charset="-120"/>
               </a:rPr>
-              <a:t>평균 130.6계단</a:t>
+              <a:t>평균 118.3계단</a:t>
             </a:r>
             <a:endParaRPr lang="en-US" sz="1000" dirty="0"/>
           </a:p>
@@ -12090,24 +12321,27 @@
         </p:nvSpPr>
         <p:spPr>
           <a:xfrm>
-            <a:off x="8641080" y="5989320"/>
-            <a:ext cx="2743200" cy="228600"/>
-          </a:xfrm>
-          <a:prstGeom prst="rect">
-            <a:avLst/>
-          </a:prstGeom>
-          <a:noFill/>
-          <a:ln/>
-        </p:spPr>
-        <p:txBody>
-          <a:bodyPr wrap="square" lIns="0" tIns="0" rIns="0" bIns="0" rtlCol="0" anchor="ctr"/>
-          <a:lstStyle/>
-          <a:p>
-            <a:pPr indent="0" marL="0">
-              <a:buNone/>
-            </a:pPr>
-            <a:r>
-              <a:rPr lang="en-US" sz="850" i="1" dirty="0">
+            <a:off x="8641080" y="5943600"/>
+            <a:ext cx="2743200" cy="365760"/>
+          </a:xfrm>
+          <a:prstGeom prst="rect">
+            <a:avLst/>
+          </a:prstGeom>
+          <a:noFill/>
+          <a:ln/>
+        </p:spPr>
+        <p:txBody>
+          <a:bodyPr wrap="square" lIns="0" tIns="0" rIns="0" bIns="0" rtlCol="0" anchor="ctr"/>
+          <a:lstStyle/>
+          <a:p>
+            <a:pPr indent="0" marL="0">
+              <a:lnSpc>
+                <a:spcPct val="115000"/>
+              </a:lnSpc>
+              <a:buNone/>
+            </a:pPr>
+            <a:r>
+              <a:rPr lang="en-US" sz="830" i="1" dirty="0">
                 <a:solidFill>
                   <a:srgbClr val="8B8FA3"/>
                 </a:solidFill>
@@ -12115,9 +12349,9 @@
                 <a:ea typeface="Calibri" pitchFamily="34" charset="-122"/>
                 <a:cs typeface="Calibri" pitchFamily="34" charset="-120"/>
               </a:rPr>
-              <a:t>※ 검은사막M은 데이터가 있는 5주 기준(3월 이후 대부분 미집계)</a:t>
-            </a:r>
-            <a:endParaRPr lang="en-US" sz="850" dirty="0"/>
+              <a:t>※ 검은사막M: 200위 이상/미집계 주는 200으로 클램프 후 산출(39주 전체)</a:t>
+            </a:r>
+            <a:endParaRPr lang="en-US" sz="830" dirty="0"/>
           </a:p>
         </p:txBody>
       </p:sp>

</xml_diff>

<commit_message>
Fix clipped MapleStory M line on two event-correlation charts
The mabinogi and aion2 event-correlation charts fixed their y-axis max
to the competitor's own range (60 and 70) without accounting for
MapleStory M's own rank, which reaches 98. Any week where Maple's line
exceeded the axis ceiling was clipped off entirely, showing as a
broken/missing line segment. Raised both to 0-100 and re-verified
every chart in the deck's axis bounds against its actual data min/max
in bulk to catch any other instance of this bug — none found.

Co-Authored-By: Claude Sonnet 5 <noreply@anthropic.com>
Claude-Session: https://claude.ai/code/session_01KLgeNtKXrj11AxxgcqzV4e
</commit_message>
<xml_diff>
--- a/output/메이플스토리M_UA마케팅효율_분석보고서.pptx
+++ b/output/메이플스토리M_UA마케팅효율_분석보고서.pptx
@@ -1884,7 +1884,7 @@
         <c:axId val="2094734552"/>
         <c:scaling>
           <c:orientation val="minMax"/>
-          <c:max val="60"/>
+          <c:max val="100"/>
           <c:min val="0"/>
         </c:scaling>
         <c:delete val="0"/>
@@ -1958,7 +1958,7 @@
         <c:crossAx val="2094734554"/>
         <c:crosses val="autoZero"/>
         <c:crossBetween val="between"/>
-        <c:majorUnit val="10"/>
+        <c:majorUnit val="20"/>
       </c:valAx>
       <c:spPr>
         <a:noFill/>
@@ -3264,7 +3264,7 @@
         <c:axId val="2094734552"/>
         <c:scaling>
           <c:orientation val="minMax"/>
-          <c:max val="70"/>
+          <c:max val="100"/>
           <c:min val="0"/>
         </c:scaling>
         <c:delete val="0"/>
@@ -3338,7 +3338,7 @@
         <c:crossAx val="2094734554"/>
         <c:crosses val="autoZero"/>
         <c:crossBetween val="between"/>
-        <c:majorUnit val="10"/>
+        <c:majorUnit val="20"/>
       </c:valAx>
       <c:spPr>
         <a:noFill/>

</xml_diff>